<commit_message>
Keep slide shapes within bounds; add PDF and PNG versions of the handout
Co-Authored-By: Claude Opus 5.5 <noreply@anthropic.com>
Claude-Session: https://claude.ai/code/session_019XJo9VtDvkwAdk2Euigc1F
</commit_message>
<xml_diff>
--- a/line_delivery/screening_time_steps.pptx
+++ b/line_delivery/screening_time_steps.pptx
@@ -1506,8 +1506,8 @@
         </p:nvSpPr>
         <p:spPr>
           <a:xfrm>
-            <a:off x="6309360" y="-1097280"/>
-            <a:ext cx="4114800" cy="4114800"/>
+            <a:off x="6035040" y="548640"/>
+            <a:ext cx="2560320" cy="2560320"/>
           </a:xfrm>
           <a:prstGeom prst="ellipse">
             <a:avLst/>
@@ -1531,8 +1531,8 @@
         </p:nvSpPr>
         <p:spPr>
           <a:xfrm>
-            <a:off x="7223760" y="3108960"/>
-            <a:ext cx="2743200" cy="2743200"/>
+            <a:off x="7406640" y="3200400"/>
+            <a:ext cx="1371600" cy="1371600"/>
           </a:xfrm>
           <a:prstGeom prst="ellipse">
             <a:avLst/>
@@ -6710,8 +6710,8 @@
         </p:nvSpPr>
         <p:spPr>
           <a:xfrm>
-            <a:off x="-1097280" y="2926080"/>
-            <a:ext cx="3657600" cy="3657600"/>
+            <a:off x="457200" y="3566160"/>
+            <a:ext cx="1097280" cy="1097280"/>
           </a:xfrm>
           <a:prstGeom prst="ellipse">
             <a:avLst/>
@@ -6735,8 +6735,8 @@
         </p:nvSpPr>
         <p:spPr>
           <a:xfrm>
-            <a:off x="6949440" y="-1188720"/>
-            <a:ext cx="3291840" cy="3291840"/>
+            <a:off x="7498080" y="457200"/>
+            <a:ext cx="1188720" cy="1188720"/>
           </a:xfrm>
           <a:prstGeom prst="ellipse">
             <a:avLst/>

</xml_diff>